<commit_message>
Update INARA 2026-09-01 12:59:48
</commit_message>
<xml_diff>
--- a/reports/BRANCH_DENPASAR_PERFORMANCE_SUMMARY_20260831_INARA.pptx
+++ b/reports/BRANCH_DENPASAR_PERFORMANCE_SUMMARY_20260831_INARA.pptx
@@ -13625,7 +13625,7 @@
                 </a:solidFill>
                 <a:latin typeface="Arial"/>
               </a:rPr>
-              <a:t>211</a:t>
+              <a:t>220</a:t>
             </a:r>
           </a:p>
         </p:txBody>
@@ -13656,11 +13656,11 @@
             <a:r>
               <a:rPr sz="1200" b="1" i="0">
                 <a:solidFill>
-                  <a:srgbClr val="137D3F"/>
+                  <a:srgbClr val="687386"/>
                 </a:solidFill>
                 <a:latin typeface="Arial"/>
               </a:rPr>
-              <a:t>+1,9%</a:t>
+              <a:t>N/A</a:t>
             </a:r>
           </a:p>
         </p:txBody>
@@ -13695,7 +13695,7 @@
                 </a:solidFill>
                 <a:latin typeface="Arial"/>
               </a:rPr>
-              <a:t>MTD-1: 207   Δ 4</a:t>
+              <a:t>MTD-1: 0   Δ 220</a:t>
             </a:r>
           </a:p>
         </p:txBody>
@@ -13812,7 +13812,7 @@
                 </a:solidFill>
                 <a:latin typeface="Arial"/>
               </a:rPr>
-              <a:t>6.012</a:t>
+              <a:t>6.435</a:t>
             </a:r>
           </a:p>
         </p:txBody>
@@ -13843,11 +13843,11 @@
             <a:r>
               <a:rPr sz="1200" b="1" i="0">
                 <a:solidFill>
-                  <a:srgbClr val="D73527"/>
+                  <a:srgbClr val="687386"/>
                 </a:solidFill>
                 <a:latin typeface="Arial"/>
               </a:rPr>
-              <a:t>-5,3%</a:t>
+              <a:t>N/A</a:t>
             </a:r>
           </a:p>
         </p:txBody>
@@ -13882,7 +13882,7 @@
                 </a:solidFill>
                 <a:latin typeface="Arial"/>
               </a:rPr>
-              <a:t>MTD-1: 6.349   Δ -337</a:t>
+              <a:t>MTD-1: 0   Δ 6.435</a:t>
             </a:r>
           </a:p>
         </p:txBody>
@@ -15018,7 +15018,7 @@
                           </a:solidFill>
                           <a:latin typeface="Arial"/>
                         </a:rPr>
-                        <a:t>49</a:t>
+                        <a:t>0</a:t>
                       </a:r>
                     </a:p>
                   </a:txBody>
@@ -15065,7 +15065,7 @@
                           </a:solidFill>
                           <a:latin typeface="Arial"/>
                         </a:rPr>
-                        <a:t>50</a:t>
+                        <a:t>54</a:t>
                       </a:r>
                     </a:p>
                   </a:txBody>
@@ -15108,17 +15108,17 @@
                       <a:r>
                         <a:rPr sz="1050" b="0">
                           <a:solidFill>
-                            <a:srgbClr val="137D3F"/>
-                          </a:solidFill>
-                          <a:latin typeface="Arial"/>
-                        </a:rPr>
-                        <a:t>+2,0%</a:t>
-                      </a:r>
-                    </a:p>
-                  </a:txBody>
-                  <a:tcPr marL="27432" marR="27432" marT="0" marB="0">
-                    <a:solidFill>
-                      <a:srgbClr val="E5F4EA"/>
+                            <a:srgbClr val="687386"/>
+                          </a:solidFill>
+                          <a:latin typeface="Arial"/>
+                        </a:rPr>
+                        <a:t>N/A</a:t>
+                      </a:r>
+                    </a:p>
+                  </a:txBody>
+                  <a:tcPr marL="27432" marR="27432" marT="0" marB="0">
+                    <a:solidFill>
+                      <a:srgbClr val="E9EDF2"/>
                     </a:solidFill>
                     <a:lnL w="9000" cap="flat" cmpd="sng" algn="ctr">
                       <a:solidFill>
@@ -15159,7 +15159,7 @@
                           </a:solidFill>
                           <a:latin typeface="Arial"/>
                         </a:rPr>
-                        <a:t>2.104</a:t>
+                        <a:t>0</a:t>
                       </a:r>
                     </a:p>
                   </a:txBody>
@@ -15206,7 +15206,7 @@
                           </a:solidFill>
                           <a:latin typeface="Arial"/>
                         </a:rPr>
-                        <a:t>1.250</a:t>
+                        <a:t>1.339</a:t>
                       </a:r>
                     </a:p>
                   </a:txBody>
@@ -15249,17 +15249,17 @@
                       <a:r>
                         <a:rPr sz="1050" b="0">
                           <a:solidFill>
-                            <a:srgbClr val="D73527"/>
-                          </a:solidFill>
-                          <a:latin typeface="Arial"/>
-                        </a:rPr>
-                        <a:t>-40,6%</a:t>
-                      </a:r>
-                    </a:p>
-                  </a:txBody>
-                  <a:tcPr marL="27432" marR="27432" marT="0" marB="0">
-                    <a:solidFill>
-                      <a:srgbClr val="FBE9E7"/>
+                            <a:srgbClr val="687386"/>
+                          </a:solidFill>
+                          <a:latin typeface="Arial"/>
+                        </a:rPr>
+                        <a:t>N/A</a:t>
+                      </a:r>
+                    </a:p>
+                  </a:txBody>
+                  <a:tcPr marL="27432" marR="27432" marT="0" marB="0">
+                    <a:solidFill>
+                      <a:srgbClr val="E9EDF2"/>
                     </a:solidFill>
                     <a:lnL w="9000" cap="flat" cmpd="sng" algn="ctr">
                       <a:solidFill>
@@ -15678,7 +15678,7 @@
                           </a:solidFill>
                           <a:latin typeface="Arial"/>
                         </a:rPr>
-                        <a:t>74</a:t>
+                        <a:t>0</a:t>
                       </a:r>
                     </a:p>
                   </a:txBody>
@@ -15725,7 +15725,7 @@
                           </a:solidFill>
                           <a:latin typeface="Arial"/>
                         </a:rPr>
-                        <a:t>81</a:t>
+                        <a:t>84</a:t>
                       </a:r>
                     </a:p>
                   </a:txBody>
@@ -15768,17 +15768,17 @@
                       <a:r>
                         <a:rPr sz="1050" b="0">
                           <a:solidFill>
-                            <a:srgbClr val="137D3F"/>
-                          </a:solidFill>
-                          <a:latin typeface="Arial"/>
-                        </a:rPr>
-                        <a:t>+9,5%</a:t>
-                      </a:r>
-                    </a:p>
-                  </a:txBody>
-                  <a:tcPr marL="27432" marR="27432" marT="0" marB="0">
-                    <a:solidFill>
-                      <a:srgbClr val="E5F4EA"/>
+                            <a:srgbClr val="687386"/>
+                          </a:solidFill>
+                          <a:latin typeface="Arial"/>
+                        </a:rPr>
+                        <a:t>N/A</a:t>
+                      </a:r>
+                    </a:p>
+                  </a:txBody>
+                  <a:tcPr marL="27432" marR="27432" marT="0" marB="0">
+                    <a:solidFill>
+                      <a:srgbClr val="E9EDF2"/>
                     </a:solidFill>
                     <a:lnL w="9000" cap="flat" cmpd="sng" algn="ctr">
                       <a:solidFill>
@@ -15819,7 +15819,7 @@
                           </a:solidFill>
                           <a:latin typeface="Arial"/>
                         </a:rPr>
-                        <a:t>1.840</a:t>
+                        <a:t>0</a:t>
                       </a:r>
                     </a:p>
                   </a:txBody>
@@ -15866,7 +15866,7 @@
                           </a:solidFill>
                           <a:latin typeface="Arial"/>
                         </a:rPr>
-                        <a:t>1.909</a:t>
+                        <a:t>1.998</a:t>
                       </a:r>
                     </a:p>
                   </a:txBody>
@@ -15909,17 +15909,17 @@
                       <a:r>
                         <a:rPr sz="1050" b="0">
                           <a:solidFill>
-                            <a:srgbClr val="137D3F"/>
-                          </a:solidFill>
-                          <a:latin typeface="Arial"/>
-                        </a:rPr>
-                        <a:t>+3,8%</a:t>
-                      </a:r>
-                    </a:p>
-                  </a:txBody>
-                  <a:tcPr marL="27432" marR="27432" marT="0" marB="0">
-                    <a:solidFill>
-                      <a:srgbClr val="E5F4EA"/>
+                            <a:srgbClr val="687386"/>
+                          </a:solidFill>
+                          <a:latin typeface="Arial"/>
+                        </a:rPr>
+                        <a:t>N/A</a:t>
+                      </a:r>
+                    </a:p>
+                  </a:txBody>
+                  <a:tcPr marL="27432" marR="27432" marT="0" marB="0">
+                    <a:solidFill>
+                      <a:srgbClr val="E9EDF2"/>
                     </a:solidFill>
                     <a:lnL w="9000" cap="flat" cmpd="sng" algn="ctr">
                       <a:solidFill>
@@ -16338,7 +16338,7 @@
                           </a:solidFill>
                           <a:latin typeface="Arial"/>
                         </a:rPr>
-                        <a:t>47</a:t>
+                        <a:t>0</a:t>
                       </a:r>
                     </a:p>
                   </a:txBody>
@@ -16385,7 +16385,7 @@
                           </a:solidFill>
                           <a:latin typeface="Arial"/>
                         </a:rPr>
-                        <a:t>43</a:t>
+                        <a:t>44</a:t>
                       </a:r>
                     </a:p>
                   </a:txBody>
@@ -16428,17 +16428,17 @@
                       <a:r>
                         <a:rPr sz="1050" b="0">
                           <a:solidFill>
-                            <a:srgbClr val="D73527"/>
-                          </a:solidFill>
-                          <a:latin typeface="Arial"/>
-                        </a:rPr>
-                        <a:t>-8,5%</a:t>
-                      </a:r>
-                    </a:p>
-                  </a:txBody>
-                  <a:tcPr marL="27432" marR="27432" marT="0" marB="0">
-                    <a:solidFill>
-                      <a:srgbClr val="FBE9E7"/>
+                            <a:srgbClr val="687386"/>
+                          </a:solidFill>
+                          <a:latin typeface="Arial"/>
+                        </a:rPr>
+                        <a:t>N/A</a:t>
+                      </a:r>
+                    </a:p>
+                  </a:txBody>
+                  <a:tcPr marL="27432" marR="27432" marT="0" marB="0">
+                    <a:solidFill>
+                      <a:srgbClr val="E9EDF2"/>
                     </a:solidFill>
                     <a:lnL w="9000" cap="flat" cmpd="sng" algn="ctr">
                       <a:solidFill>
@@ -16479,7 +16479,7 @@
                           </a:solidFill>
                           <a:latin typeface="Arial"/>
                         </a:rPr>
-                        <a:t>1.383</a:t>
+                        <a:t>0</a:t>
                       </a:r>
                     </a:p>
                   </a:txBody>
@@ -16526,7 +16526,7 @@
                           </a:solidFill>
                           <a:latin typeface="Arial"/>
                         </a:rPr>
-                        <a:t>1.682</a:t>
+                        <a:t>1.821</a:t>
                       </a:r>
                     </a:p>
                   </a:txBody>
@@ -16569,17 +16569,17 @@
                       <a:r>
                         <a:rPr sz="1050" b="0">
                           <a:solidFill>
-                            <a:srgbClr val="137D3F"/>
-                          </a:solidFill>
-                          <a:latin typeface="Arial"/>
-                        </a:rPr>
-                        <a:t>+21,6%</a:t>
-                      </a:r>
-                    </a:p>
-                  </a:txBody>
-                  <a:tcPr marL="27432" marR="27432" marT="0" marB="0">
-                    <a:solidFill>
-                      <a:srgbClr val="E5F4EA"/>
+                            <a:srgbClr val="687386"/>
+                          </a:solidFill>
+                          <a:latin typeface="Arial"/>
+                        </a:rPr>
+                        <a:t>N/A</a:t>
+                      </a:r>
+                    </a:p>
+                  </a:txBody>
+                  <a:tcPr marL="27432" marR="27432" marT="0" marB="0">
+                    <a:solidFill>
+                      <a:srgbClr val="E9EDF2"/>
                     </a:solidFill>
                     <a:lnL w="9000" cap="flat" cmpd="sng" algn="ctr">
                       <a:solidFill>
@@ -16998,7 +16998,7 @@
                           </a:solidFill>
                           <a:latin typeface="Arial"/>
                         </a:rPr>
-                        <a:t>37</a:t>
+                        <a:t>0</a:t>
                       </a:r>
                     </a:p>
                   </a:txBody>
@@ -17045,7 +17045,7 @@
                           </a:solidFill>
                           <a:latin typeface="Arial"/>
                         </a:rPr>
-                        <a:t>37</a:t>
+                        <a:t>38</a:t>
                       </a:r>
                     </a:p>
                   </a:txBody>
@@ -17092,7 +17092,7 @@
                           </a:solidFill>
                           <a:latin typeface="Arial"/>
                         </a:rPr>
-                        <a:t>0,0%</a:t>
+                        <a:t>N/A</a:t>
                       </a:r>
                     </a:p>
                   </a:txBody>
@@ -17139,7 +17139,7 @@
                           </a:solidFill>
                           <a:latin typeface="Arial"/>
                         </a:rPr>
-                        <a:t>1.022</a:t>
+                        <a:t>0</a:t>
                       </a:r>
                     </a:p>
                   </a:txBody>
@@ -17186,7 +17186,7 @@
                           </a:solidFill>
                           <a:latin typeface="Arial"/>
                         </a:rPr>
-                        <a:t>1.171</a:t>
+                        <a:t>1.277</a:t>
                       </a:r>
                     </a:p>
                   </a:txBody>
@@ -17229,17 +17229,17 @@
                       <a:r>
                         <a:rPr sz="1050" b="0">
                           <a:solidFill>
-                            <a:srgbClr val="137D3F"/>
-                          </a:solidFill>
-                          <a:latin typeface="Arial"/>
-                        </a:rPr>
-                        <a:t>+14,6%</a:t>
-                      </a:r>
-                    </a:p>
-                  </a:txBody>
-                  <a:tcPr marL="27432" marR="27432" marT="0" marB="0">
-                    <a:solidFill>
-                      <a:srgbClr val="E5F4EA"/>
+                            <a:srgbClr val="687386"/>
+                          </a:solidFill>
+                          <a:latin typeface="Arial"/>
+                        </a:rPr>
+                        <a:t>N/A</a:t>
+                      </a:r>
+                    </a:p>
+                  </a:txBody>
+                  <a:tcPr marL="27432" marR="27432" marT="0" marB="0">
+                    <a:solidFill>
+                      <a:srgbClr val="E9EDF2"/>
                     </a:solidFill>
                     <a:lnL w="9000" cap="flat" cmpd="sng" algn="ctr">
                       <a:solidFill>
@@ -26095,7 +26095,7 @@
                           </a:solidFill>
                           <a:latin typeface="Arial"/>
                         </a:rPr>
-                        <a:t>2.261</a:t>
+                        <a:t>2.323</a:t>
                       </a:r>
                     </a:p>
                   </a:txBody>
@@ -26142,7 +26142,7 @@
                           </a:solidFill>
                           <a:latin typeface="Arial"/>
                         </a:rPr>
-                        <a:t>5.061</a:t>
+                        <a:t>5.099</a:t>
                       </a:r>
                     </a:p>
                   </a:txBody>
@@ -26189,7 +26189,7 @@
                           </a:solidFill>
                           <a:latin typeface="Arial"/>
                         </a:rPr>
-                        <a:t>32.130</a:t>
+                        <a:t>32.065</a:t>
                       </a:r>
                     </a:p>
                   </a:txBody>
@@ -26236,7 +26236,7 @@
                           </a:solidFill>
                           <a:latin typeface="Arial"/>
                         </a:rPr>
-                        <a:t>4.564</a:t>
+                        <a:t>4.551</a:t>
                       </a:r>
                     </a:p>
                   </a:txBody>
@@ -26283,7 +26283,7 @@
                           </a:solidFill>
                           <a:latin typeface="Arial"/>
                         </a:rPr>
-                        <a:t>3.289</a:t>
+                        <a:t>3.324</a:t>
                       </a:r>
                     </a:p>
                   </a:txBody>
@@ -26330,7 +26330,7 @@
                           </a:solidFill>
                           <a:latin typeface="Arial"/>
                         </a:rPr>
-                        <a:t>47.305</a:t>
+                        <a:t>47.362</a:t>
                       </a:r>
                     </a:p>
                   </a:txBody>
@@ -26379,7 +26379,7 @@
                           </a:solidFill>
                           <a:latin typeface="Arial"/>
                         </a:rPr>
-                        <a:t>4,8%</a:t>
+                        <a:t>4,9%</a:t>
                       </a:r>
                     </a:p>
                   </a:txBody>
@@ -26426,7 +26426,7 @@
                           </a:solidFill>
                           <a:latin typeface="Arial"/>
                         </a:rPr>
-                        <a:t>10,7%</a:t>
+                        <a:t>10,8%</a:t>
                       </a:r>
                     </a:p>
                   </a:txBody>
@@ -26473,7 +26473,7 @@
                           </a:solidFill>
                           <a:latin typeface="Arial"/>
                         </a:rPr>
-                        <a:t>67,9%</a:t>
+                        <a:t>67,7%</a:t>
                       </a:r>
                     </a:p>
                   </a:txBody>
@@ -26800,7 +26800,7 @@
                 </a:solidFill>
                 <a:latin typeface="Arial"/>
               </a:rPr>
-              <a:t>Jumlah ODP  3.289</a:t>
+              <a:t>Jumlah ODP  3.324</a:t>
             </a:r>
           </a:p>
         </p:txBody>
@@ -26835,7 +26835,7 @@
                 </a:solidFill>
                 <a:latin typeface="Arial"/>
               </a:rPr>
-              <a:t>ODP dikunjungi  546 (16,6%)</a:t>
+              <a:t>ODP dikunjungi  589 (17,7%)</a:t>
             </a:r>
           </a:p>
         </p:txBody>
@@ -26905,7 +26905,7 @@
                 </a:solidFill>
                 <a:latin typeface="Arial"/>
               </a:rPr>
-              <a:t>1.806</a:t>
+              <a:t>1.986</a:t>
             </a:r>
           </a:p>
         </p:txBody>
@@ -27022,7 +27022,7 @@
                 </a:solidFill>
                 <a:latin typeface="Arial"/>
               </a:rPr>
-              <a:t>Jumlah ODP  328</a:t>
+              <a:t>Jumlah ODP  362</a:t>
             </a:r>
           </a:p>
         </p:txBody>
@@ -27057,7 +27057,7 @@
                 </a:solidFill>
                 <a:latin typeface="Arial"/>
               </a:rPr>
-              <a:t>ODP dikunjungi  201 (61,3%)</a:t>
+              <a:t>ODP dikunjungi  218 (60,2%)</a:t>
             </a:r>
           </a:p>
         </p:txBody>
@@ -27127,7 +27127,7 @@
                 </a:solidFill>
                 <a:latin typeface="Arial"/>
               </a:rPr>
-              <a:t>651</a:t>
+              <a:t>794</a:t>
             </a:r>
           </a:p>
         </p:txBody>

</xml_diff>

<commit_message>
Update INARA 2026-09-01 13:45:18
</commit_message>
<xml_diff>
--- a/reports/BRANCH_DENPASAR_PERFORMANCE_SUMMARY_20260831_INARA.pptx
+++ b/reports/BRANCH_DENPASAR_PERFORMANCE_SUMMARY_20260831_INARA.pptx
@@ -13656,11 +13656,11 @@
             <a:r>
               <a:rPr sz="1200" b="1" i="0">
                 <a:solidFill>
-                  <a:srgbClr val="687386"/>
+                  <a:srgbClr val="137D3F"/>
                 </a:solidFill>
                 <a:latin typeface="Arial"/>
               </a:rPr>
-              <a:t>N/A</a:t>
+              <a:t>+1,4%</a:t>
             </a:r>
           </a:p>
         </p:txBody>
@@ -13695,7 +13695,7 @@
                 </a:solidFill>
                 <a:latin typeface="Arial"/>
               </a:rPr>
-              <a:t>MTD-1: 0   Δ 220</a:t>
+              <a:t>MTD-1: 217   Δ 3</a:t>
             </a:r>
           </a:p>
         </p:txBody>
@@ -13843,11 +13843,11 @@
             <a:r>
               <a:rPr sz="1200" b="1" i="0">
                 <a:solidFill>
-                  <a:srgbClr val="687386"/>
+                  <a:srgbClr val="D73527"/>
                 </a:solidFill>
                 <a:latin typeface="Arial"/>
               </a:rPr>
-              <a:t>N/A</a:t>
+              <a:t>-5,7%</a:t>
             </a:r>
           </a:p>
         </p:txBody>
@@ -13882,7 +13882,7 @@
                 </a:solidFill>
                 <a:latin typeface="Arial"/>
               </a:rPr>
-              <a:t>MTD-1: 0   Δ 6.435</a:t>
+              <a:t>MTD-1: 6.822   Δ -387</a:t>
             </a:r>
           </a:p>
         </p:txBody>
@@ -15018,7 +15018,7 @@
                           </a:solidFill>
                           <a:latin typeface="Arial"/>
                         </a:rPr>
-                        <a:t>0</a:t>
+                        <a:t>56</a:t>
                       </a:r>
                     </a:p>
                   </a:txBody>
@@ -15108,17 +15108,17 @@
                       <a:r>
                         <a:rPr sz="1050" b="0">
                           <a:solidFill>
-                            <a:srgbClr val="687386"/>
-                          </a:solidFill>
-                          <a:latin typeface="Arial"/>
-                        </a:rPr>
-                        <a:t>N/A</a:t>
-                      </a:r>
-                    </a:p>
-                  </a:txBody>
-                  <a:tcPr marL="27432" marR="27432" marT="0" marB="0">
-                    <a:solidFill>
-                      <a:srgbClr val="E9EDF2"/>
+                            <a:srgbClr val="D73527"/>
+                          </a:solidFill>
+                          <a:latin typeface="Arial"/>
+                        </a:rPr>
+                        <a:t>-3,6%</a:t>
+                      </a:r>
+                    </a:p>
+                  </a:txBody>
+                  <a:tcPr marL="27432" marR="27432" marT="0" marB="0">
+                    <a:solidFill>
+                      <a:srgbClr val="FBE9E7"/>
                     </a:solidFill>
                     <a:lnL w="9000" cap="flat" cmpd="sng" algn="ctr">
                       <a:solidFill>
@@ -15159,7 +15159,7 @@
                           </a:solidFill>
                           <a:latin typeface="Arial"/>
                         </a:rPr>
-                        <a:t>0</a:t>
+                        <a:t>2.188</a:t>
                       </a:r>
                     </a:p>
                   </a:txBody>
@@ -15249,17 +15249,17 @@
                       <a:r>
                         <a:rPr sz="1050" b="0">
                           <a:solidFill>
-                            <a:srgbClr val="687386"/>
-                          </a:solidFill>
-                          <a:latin typeface="Arial"/>
-                        </a:rPr>
-                        <a:t>N/A</a:t>
-                      </a:r>
-                    </a:p>
-                  </a:txBody>
-                  <a:tcPr marL="27432" marR="27432" marT="0" marB="0">
-                    <a:solidFill>
-                      <a:srgbClr val="E9EDF2"/>
+                            <a:srgbClr val="D73527"/>
+                          </a:solidFill>
+                          <a:latin typeface="Arial"/>
+                        </a:rPr>
+                        <a:t>-38,8%</a:t>
+                      </a:r>
+                    </a:p>
+                  </a:txBody>
+                  <a:tcPr marL="27432" marR="27432" marT="0" marB="0">
+                    <a:solidFill>
+                      <a:srgbClr val="FBE9E7"/>
                     </a:solidFill>
                     <a:lnL w="9000" cap="flat" cmpd="sng" algn="ctr">
                       <a:solidFill>
@@ -15678,7 +15678,7 @@
                           </a:solidFill>
                           <a:latin typeface="Arial"/>
                         </a:rPr>
-                        <a:t>0</a:t>
+                        <a:t>74</a:t>
                       </a:r>
                     </a:p>
                   </a:txBody>
@@ -15768,17 +15768,17 @@
                       <a:r>
                         <a:rPr sz="1050" b="0">
                           <a:solidFill>
-                            <a:srgbClr val="687386"/>
-                          </a:solidFill>
-                          <a:latin typeface="Arial"/>
-                        </a:rPr>
-                        <a:t>N/A</a:t>
-                      </a:r>
-                    </a:p>
-                  </a:txBody>
-                  <a:tcPr marL="27432" marR="27432" marT="0" marB="0">
-                    <a:solidFill>
-                      <a:srgbClr val="E9EDF2"/>
+                            <a:srgbClr val="137D3F"/>
+                          </a:solidFill>
+                          <a:latin typeface="Arial"/>
+                        </a:rPr>
+                        <a:t>+13,5%</a:t>
+                      </a:r>
+                    </a:p>
+                  </a:txBody>
+                  <a:tcPr marL="27432" marR="27432" marT="0" marB="0">
+                    <a:solidFill>
+                      <a:srgbClr val="E5F4EA"/>
                     </a:solidFill>
                     <a:lnL w="9000" cap="flat" cmpd="sng" algn="ctr">
                       <a:solidFill>
@@ -15819,7 +15819,7 @@
                           </a:solidFill>
                           <a:latin typeface="Arial"/>
                         </a:rPr>
-                        <a:t>0</a:t>
+                        <a:t>2.069</a:t>
                       </a:r>
                     </a:p>
                   </a:txBody>
@@ -15909,17 +15909,17 @@
                       <a:r>
                         <a:rPr sz="1050" b="0">
                           <a:solidFill>
-                            <a:srgbClr val="687386"/>
-                          </a:solidFill>
-                          <a:latin typeface="Arial"/>
-                        </a:rPr>
-                        <a:t>N/A</a:t>
-                      </a:r>
-                    </a:p>
-                  </a:txBody>
-                  <a:tcPr marL="27432" marR="27432" marT="0" marB="0">
-                    <a:solidFill>
-                      <a:srgbClr val="E9EDF2"/>
+                            <a:srgbClr val="D73527"/>
+                          </a:solidFill>
+                          <a:latin typeface="Arial"/>
+                        </a:rPr>
+                        <a:t>-3,4%</a:t>
+                      </a:r>
+                    </a:p>
+                  </a:txBody>
+                  <a:tcPr marL="27432" marR="27432" marT="0" marB="0">
+                    <a:solidFill>
+                      <a:srgbClr val="FBE9E7"/>
                     </a:solidFill>
                     <a:lnL w="9000" cap="flat" cmpd="sng" algn="ctr">
                       <a:solidFill>
@@ -16338,7 +16338,7 @@
                           </a:solidFill>
                           <a:latin typeface="Arial"/>
                         </a:rPr>
-                        <a:t>0</a:t>
+                        <a:t>50</a:t>
                       </a:r>
                     </a:p>
                   </a:txBody>
@@ -16428,17 +16428,17 @@
                       <a:r>
                         <a:rPr sz="1050" b="0">
                           <a:solidFill>
-                            <a:srgbClr val="687386"/>
-                          </a:solidFill>
-                          <a:latin typeface="Arial"/>
-                        </a:rPr>
-                        <a:t>N/A</a:t>
-                      </a:r>
-                    </a:p>
-                  </a:txBody>
-                  <a:tcPr marL="27432" marR="27432" marT="0" marB="0">
-                    <a:solidFill>
-                      <a:srgbClr val="E9EDF2"/>
+                            <a:srgbClr val="D73527"/>
+                          </a:solidFill>
+                          <a:latin typeface="Arial"/>
+                        </a:rPr>
+                        <a:t>-12,0%</a:t>
+                      </a:r>
+                    </a:p>
+                  </a:txBody>
+                  <a:tcPr marL="27432" marR="27432" marT="0" marB="0">
+                    <a:solidFill>
+                      <a:srgbClr val="FBE9E7"/>
                     </a:solidFill>
                     <a:lnL w="9000" cap="flat" cmpd="sng" algn="ctr">
                       <a:solidFill>
@@ -16479,7 +16479,7 @@
                           </a:solidFill>
                           <a:latin typeface="Arial"/>
                         </a:rPr>
-                        <a:t>0</a:t>
+                        <a:t>1.526</a:t>
                       </a:r>
                     </a:p>
                   </a:txBody>
@@ -16569,17 +16569,17 @@
                       <a:r>
                         <a:rPr sz="1050" b="0">
                           <a:solidFill>
-                            <a:srgbClr val="687386"/>
-                          </a:solidFill>
-                          <a:latin typeface="Arial"/>
-                        </a:rPr>
-                        <a:t>N/A</a:t>
-                      </a:r>
-                    </a:p>
-                  </a:txBody>
-                  <a:tcPr marL="27432" marR="27432" marT="0" marB="0">
-                    <a:solidFill>
-                      <a:srgbClr val="E9EDF2"/>
+                            <a:srgbClr val="137D3F"/>
+                          </a:solidFill>
+                          <a:latin typeface="Arial"/>
+                        </a:rPr>
+                        <a:t>+19,3%</a:t>
+                      </a:r>
+                    </a:p>
+                  </a:txBody>
+                  <a:tcPr marL="27432" marR="27432" marT="0" marB="0">
+                    <a:solidFill>
+                      <a:srgbClr val="E5F4EA"/>
                     </a:solidFill>
                     <a:lnL w="9000" cap="flat" cmpd="sng" algn="ctr">
                       <a:solidFill>
@@ -16998,7 +16998,7 @@
                           </a:solidFill>
                           <a:latin typeface="Arial"/>
                         </a:rPr>
-                        <a:t>0</a:t>
+                        <a:t>37</a:t>
                       </a:r>
                     </a:p>
                   </a:txBody>
@@ -17088,17 +17088,17 @@
                       <a:r>
                         <a:rPr sz="1050" b="0">
                           <a:solidFill>
-                            <a:srgbClr val="687386"/>
-                          </a:solidFill>
-                          <a:latin typeface="Arial"/>
-                        </a:rPr>
-                        <a:t>N/A</a:t>
-                      </a:r>
-                    </a:p>
-                  </a:txBody>
-                  <a:tcPr marL="27432" marR="27432" marT="0" marB="0">
-                    <a:solidFill>
-                      <a:srgbClr val="E9EDF2"/>
+                            <a:srgbClr val="137D3F"/>
+                          </a:solidFill>
+                          <a:latin typeface="Arial"/>
+                        </a:rPr>
+                        <a:t>+2,7%</a:t>
+                      </a:r>
+                    </a:p>
+                  </a:txBody>
+                  <a:tcPr marL="27432" marR="27432" marT="0" marB="0">
+                    <a:solidFill>
+                      <a:srgbClr val="E5F4EA"/>
                     </a:solidFill>
                     <a:lnL w="9000" cap="flat" cmpd="sng" algn="ctr">
                       <a:solidFill>
@@ -17139,7 +17139,7 @@
                           </a:solidFill>
                           <a:latin typeface="Arial"/>
                         </a:rPr>
-                        <a:t>0</a:t>
+                        <a:t>1.039</a:t>
                       </a:r>
                     </a:p>
                   </a:txBody>
@@ -17229,17 +17229,17 @@
                       <a:r>
                         <a:rPr sz="1050" b="0">
                           <a:solidFill>
-                            <a:srgbClr val="687386"/>
-                          </a:solidFill>
-                          <a:latin typeface="Arial"/>
-                        </a:rPr>
-                        <a:t>N/A</a:t>
-                      </a:r>
-                    </a:p>
-                  </a:txBody>
-                  <a:tcPr marL="27432" marR="27432" marT="0" marB="0">
-                    <a:solidFill>
-                      <a:srgbClr val="E9EDF2"/>
+                            <a:srgbClr val="137D3F"/>
+                          </a:solidFill>
+                          <a:latin typeface="Arial"/>
+                        </a:rPr>
+                        <a:t>+22,9%</a:t>
+                      </a:r>
+                    </a:p>
+                  </a:txBody>
+                  <a:tcPr marL="27432" marR="27432" marT="0" marB="0">
+                    <a:solidFill>
+                      <a:srgbClr val="E5F4EA"/>
                     </a:solidFill>
                     <a:lnL w="9000" cap="flat" cmpd="sng" algn="ctr">
                       <a:solidFill>

</xml_diff>

<commit_message>
Update INARA 2026-09-02 22:05:52
</commit_message>
<xml_diff>
--- a/reports/BRANCH_DENPASAR_PERFORMANCE_SUMMARY_20260831_INARA.pptx
+++ b/reports/BRANCH_DENPASAR_PERFORMANCE_SUMMARY_20260831_INARA.pptx
@@ -26837,7 +26837,7 @@
                 </a:solidFill>
                 <a:latin typeface="Arial"/>
               </a:rPr>
-              <a:t>ODP dikunjungi  589 (17,7%)</a:t>
+              <a:t>ODP dikunjungi  654 (19,7%)</a:t>
             </a:r>
           </a:p>
         </p:txBody>
@@ -26907,7 +26907,7 @@
                 </a:solidFill>
                 <a:latin typeface="Arial"/>
               </a:rPr>
-              <a:t>1.986</a:t>
+              <a:t>3.775</a:t>
             </a:r>
           </a:p>
         </p:txBody>
@@ -27059,7 +27059,7 @@
                 </a:solidFill>
                 <a:latin typeface="Arial"/>
               </a:rPr>
-              <a:t>ODP dikunjungi  218 (60,2%)</a:t>
+              <a:t>ODP dikunjungi  238 (65,7%)</a:t>
             </a:r>
           </a:p>
         </p:txBody>
@@ -27129,7 +27129,7 @@
                 </a:solidFill>
                 <a:latin typeface="Arial"/>
               </a:rPr>
-              <a:t>794</a:t>
+              <a:t>1.382</a:t>
             </a:r>
           </a:p>
         </p:txBody>

</xml_diff>